<commit_message>
fix: mejora leyendas y notas de la figura 6
</commit_message>
<xml_diff>
--- a/presentacion/presentacion-clusters-departamentales.pptx
+++ b/presentacion/presentacion-clusters-departamentales.pptx
@@ -618,42 +618,27 @@
           </a:p>
           <a:p>
             <a:r>
-              <a:t>15</a:t>
-            </a:r>
-          </a:p>
-          <a:p>
-            <a:r>
               <a:t>10</a:t>
             </a:r>
           </a:p>
           <a:p>
             <a:r>
-              <a:t>5</a:t>
-            </a:r>
-          </a:p>
-          <a:p>
-            <a:r>
               <a:t>0</a:t>
             </a:r>
           </a:p>
           <a:p>
             <a:r>
-              <a:t>5</a:t>
-            </a:r>
-          </a:p>
-          <a:p>
-            <a:r>
               <a:t>10</a:t>
             </a:r>
           </a:p>
           <a:p>
             <a:r>
-              <a:t>Diferencial de crecimiento (pp) · IC 95%</a:t>
-            </a:r>
-          </a:p>
-          <a:p>
-            <a:r>
-              <a:t>2020 · Minero enclave</a:t>
+              <a:t>Diferencial de crecimiento (pp)</a:t>
+            </a:r>
+          </a:p>
+          <a:p>
+            <a:r>
+              <a:t>2020 · Enclave minero</a:t>
             </a:r>
           </a:p>
           <a:p>
@@ -668,7 +653,7 @@
           </a:p>
           <a:p>
             <a:r>
-              <a:t>2021 2023 · Minero enclave</a:t>
+              <a:t>2021 2023 · Enclave minero</a:t>
             </a:r>
           </a:p>
           <a:p>
@@ -683,7 +668,37 @@
           </a:p>
           <a:p>
             <a:r>
-              <a:t>Tasas anuales</a:t>
+              <a:t>A. Tasas anuales (M1 y M4)</a:t>
+            </a:r>
+          </a:p>
+          <a:p>
+            <a:r>
+              <a:t>20</a:t>
+            </a:r>
+          </a:p>
+          <a:p>
+            <a:r>
+              <a:t>10</a:t>
+            </a:r>
+          </a:p>
+          <a:p>
+            <a:r>
+              <a:t>0</a:t>
+            </a:r>
+          </a:p>
+          <a:p>
+            <a:r>
+              <a:t>10</a:t>
+            </a:r>
+          </a:p>
+          <a:p>
+            <a:r>
+              <a:t>Diferencial del índice (puntos)</a:t>
+            </a:r>
+          </a:p>
+          <a:p>
+            <a:r>
+              <a:t>B. Niveles indexados (M5)</a:t>
             </a:r>
           </a:p>
           <a:p>
@@ -698,37 +713,17 @@
           </a:p>
           <a:p>
             <a:r>
-              <a:t>20</a:t>
-            </a:r>
-          </a:p>
-          <a:p>
-            <a:r>
-              <a:t>10</a:t>
-            </a:r>
-          </a:p>
-          <a:p>
-            <a:r>
-              <a:t>0</a:t>
-            </a:r>
-          </a:p>
-          <a:p>
-            <a:r>
-              <a:t>10</a:t>
-            </a:r>
-          </a:p>
-          <a:p>
-            <a:r>
-              <a:t>Diferencial del índice (puntos) · IC 95%</a:t>
-            </a:r>
-          </a:p>
-          <a:p>
-            <a:r>
-              <a:t>M5 · referencia: diversificado / agro</a:t>
-            </a:r>
-          </a:p>
-          <a:p>
-            <a:r>
-              <a:t>Niveles indexados</a:t>
+              <a:t>Enclave minero</a:t>
+            </a:r>
+          </a:p>
+          <a:p>
+            <a:r>
+              <a:t>Minero diversificado</a:t>
+            </a:r>
+          </a:p>
+          <a:p>
+            <a:r>
+              <a:t>Servicios / manufactura</a:t>
             </a:r>
           </a:p>
           <a:p>
@@ -6688,7 +6683,7 @@
       <p:grpSpPr/>
       <p:pic>
         <p:nvPicPr>
-          <p:cNvPr id="2" name="Picture 1" descr="Diapositiva 10. Las tasas y los niveles muestran contrastes distintos 15 10 5 0 5 10 Diferencial de crecimiento (pp) · IC 95% 2020 · Minero enclave 2020 · Minero diversificado 2020 · Servicios / manufactura 2021 2023 · Minero enclave 2021 2023 · Minero diversificado 2021 2023 · Servicios / manufactura Tasas anuales M1 · muestra completa M4 · sin Apurímac 2016 20 10 0 10 Diferencial del índice (puntos) · IC 95% M5 · referencia: diversificado / agro Niveles indexados Los intervalos muestran la incertidumbre. M5 estima un cambio relativo de -10.92 puntos en encla- ves durante 2021–2023 (p = 0,0029). Fuente: PanelOLS con efectos fijos departamentales; IC de la distribución t del estimador, errores agrupados por departamento. Escalas independientes. CCDE | Estructura productiva y recuperación regional 10 "/>
+          <p:cNvPr id="2" name="Picture 1" descr="Diapositiva 10. Las tasas y los niveles muestran contrastes distintos 10 0 10 Diferencial de crecimiento (pp) 2020 · Enclave minero 2020 · Minero diversificado 2020 · Servicios / manufactura 2021 2023 · Enclave minero 2021 2023 · Minero diversificado 2021 2023 · Servicios / manufactura A. Tasas anuales (M1 y M4) 20 10 0 10 Diferencial del índice (puntos) B. Niveles indexados (M5) M1 · muestra completa M4 · sin Apurímac 2016 Enclave minero Minero diversificado Servicios / manufactura Los intervalos muestran la incertidumbre. M5 estima un cambio relativo de -10.92 puntos en encla- ves durante 2021–2023 (p = 0,0029). Fuente: PanelOLS con efectos fijos departamentales; IC de la distribución t del estimador, errores agrupados por departamento. Escalas independientes. CCDE | Estructura productiva y recuperación regional 10 "/>
           <p:cNvPicPr>
             <a:picLocks noChangeAspect="1"/>
           </p:cNvPicPr>

</xml_diff>